<commit_message>
Add C07 15 menit vs gym carousel; fix punctuation after highlights in PPTX builder
Co-Authored-By: Claude Sonnet 5.5 <noreply@anthropic.com>
Claude-Session: https://claude.ai/code/session_013RWrZY7Vk6d3R8BExQoLnL
</commit_message>
<xml_diff>
--- a/carousel-output/C04-recap-kickoff/C04.pptx
+++ b/carousel-output/C04-recap-kickoff/C04.pptx
@@ -5105,11 +5105,11 @@
         <p:spPr>
           <a:xfrm>
             <a:off x="762000" y="8704136"/>
-            <a:ext cx="8763000" cy="2857500"/>
+            <a:ext cx="8763000" cy="2095500"/>
           </a:xfrm>
           <a:prstGeom prst="roundRect">
             <a:avLst>
-              <a:gd name="adj" fmla="val 13333"/>
+              <a:gd name="adj" fmla="val 18181"/>
             </a:avLst>
           </a:prstGeom>
           <a:solidFill>
@@ -5159,7 +5159,7 @@
                 </a:solidFill>
                 <a:latin typeface="Poppins Medium"/>
               </a:rPr>
-              <a:t>FOTO MOMEN SESI 1: tangkapan layar Google Meet (3 pembicara + peserta) atau foto dokumentasi</a:t>
+              <a:t>FOTO MOMEN SESI 1 (screenshot Meet / dokumentasi)</a:t>
             </a:r>
           </a:p>
         </p:txBody>
@@ -5858,7 +5858,7 @@
         </p:nvSpPr>
         <p:spPr>
           <a:xfrm>
-            <a:off x="762000" y="2000250"/>
+            <a:off x="762000" y="2627471"/>
             <a:ext cx="8763000" cy="1000125"/>
           </a:xfrm>
           <a:prstGeom prst="rect">
@@ -5899,12 +5899,12 @@
         </p:nvSpPr>
         <p:spPr>
           <a:xfrm>
-            <a:off x="762000" y="3286125"/>
-            <a:ext cx="8763000" cy="3581400"/>
+            <a:off x="762000" y="3913346"/>
+            <a:ext cx="8763000" cy="2247900"/>
           </a:xfrm>
           <a:prstGeom prst="roundRect">
             <a:avLst>
-              <a:gd name="adj" fmla="val 10638"/>
+              <a:gd name="adj" fmla="val 16949"/>
             </a:avLst>
           </a:prstGeom>
           <a:solidFill>
@@ -5931,8 +5931,8 @@
         </p:nvSpPr>
         <p:spPr>
           <a:xfrm>
-            <a:off x="1257300" y="3743325"/>
-            <a:ext cx="7772400" cy="2667000"/>
+            <a:off x="1257300" y="4370546"/>
+            <a:ext cx="7772400" cy="1333500"/>
           </a:xfrm>
           <a:prstGeom prst="rect">
             <a:avLst/>
@@ -5957,7 +5957,7 @@
                 </a:solidFill>
                 <a:latin typeface="Poppins Medium"/>
               </a:rPr>
-              <a:t>[KUTIPAN SINGKAT NON-DATA dari Dr. I Gusti Ngurah Bayu Darma Putra, tema Mind &amp; Resilience]</a:t>
+              <a:t>[Kutipan singkat non-data dari Dr. Bayu]</a:t>
             </a:r>
           </a:p>
         </p:txBody>
@@ -5970,7 +5970,7 @@
         </p:nvSpPr>
         <p:spPr>
           <a:xfrm>
-            <a:off x="762000" y="7153275"/>
+            <a:off x="762000" y="6446996"/>
             <a:ext cx="7231707" cy="568642"/>
           </a:xfrm>
           <a:prstGeom prst="roundRect">
@@ -6017,7 +6017,7 @@
         </p:nvSpPr>
         <p:spPr>
           <a:xfrm>
-            <a:off x="762000" y="8007668"/>
+            <a:off x="762000" y="7301389"/>
             <a:ext cx="8763000" cy="453390"/>
           </a:xfrm>
           <a:prstGeom prst="rect">
@@ -6056,12 +6056,12 @@
         </p:nvSpPr>
         <p:spPr>
           <a:xfrm>
-            <a:off x="762000" y="8746808"/>
-            <a:ext cx="8763000" cy="2286000"/>
+            <a:off x="762000" y="8040529"/>
+            <a:ext cx="8763000" cy="1809750"/>
           </a:xfrm>
           <a:prstGeom prst="roundRect">
             <a:avLst>
-              <a:gd name="adj" fmla="val 16666"/>
+              <a:gd name="adj" fmla="val 21052"/>
             </a:avLst>
           </a:prstGeom>
           <a:solidFill>
@@ -6111,7 +6111,7 @@
                 </a:solidFill>
                 <a:latin typeface="Poppins Medium"/>
               </a:rPr>
-              <a:t>FOTO HEADSHOT Dr. Bayu (cutout PNG)</a:t>
+              <a:t>HEADSHOT Dr. Bayu (cutout PNG)</a:t>
             </a:r>
           </a:p>
         </p:txBody>
@@ -6728,7 +6728,7 @@
         </p:nvSpPr>
         <p:spPr>
           <a:xfrm>
-            <a:off x="762000" y="2055971"/>
+            <a:off x="762000" y="2627471"/>
             <a:ext cx="8763000" cy="1000125"/>
           </a:xfrm>
           <a:prstGeom prst="rect">
@@ -6769,12 +6769,12 @@
         </p:nvSpPr>
         <p:spPr>
           <a:xfrm>
-            <a:off x="762000" y="3341846"/>
-            <a:ext cx="8763000" cy="2914650"/>
+            <a:off x="762000" y="3913346"/>
+            <a:ext cx="8763000" cy="2247900"/>
           </a:xfrm>
           <a:prstGeom prst="roundRect">
             <a:avLst>
-              <a:gd name="adj" fmla="val 13071"/>
+              <a:gd name="adj" fmla="val 16949"/>
             </a:avLst>
           </a:prstGeom>
           <a:solidFill>
@@ -6801,8 +6801,8 @@
         </p:nvSpPr>
         <p:spPr>
           <a:xfrm>
-            <a:off x="1257300" y="3799046"/>
-            <a:ext cx="7772400" cy="2000250"/>
+            <a:off x="1257300" y="4370546"/>
+            <a:ext cx="7772400" cy="1333500"/>
           </a:xfrm>
           <a:prstGeom prst="rect">
             <a:avLst/>
@@ -6827,7 +6827,7 @@
                 </a:solidFill>
                 <a:latin typeface="Poppins Medium"/>
               </a:rPr>
-              <a:t>[KUTIPAN SINGKAT NON-DATA dari Ferry Distira Herlangga, tema Fitness &amp; Performance]</a:t>
+              <a:t>[Kutipan singkat non-data dari Ferry]</a:t>
             </a:r>
           </a:p>
         </p:txBody>
@@ -6840,7 +6840,7 @@
         </p:nvSpPr>
         <p:spPr>
           <a:xfrm>
-            <a:off x="762000" y="6542246"/>
+            <a:off x="762000" y="6446996"/>
             <a:ext cx="4810423" cy="568642"/>
           </a:xfrm>
           <a:prstGeom prst="roundRect">
@@ -6887,7 +6887,7 @@
         </p:nvSpPr>
         <p:spPr>
           <a:xfrm>
-            <a:off x="762000" y="7396639"/>
+            <a:off x="762000" y="7301389"/>
             <a:ext cx="8763000" cy="453390"/>
           </a:xfrm>
           <a:prstGeom prst="rect">
@@ -6926,12 +6926,12 @@
         </p:nvSpPr>
         <p:spPr>
           <a:xfrm>
-            <a:off x="762000" y="8135779"/>
-            <a:ext cx="8763000" cy="2286000"/>
+            <a:off x="762000" y="8040529"/>
+            <a:ext cx="8763000" cy="1809750"/>
           </a:xfrm>
           <a:prstGeom prst="roundRect">
             <a:avLst>
-              <a:gd name="adj" fmla="val 16666"/>
+              <a:gd name="adj" fmla="val 21052"/>
             </a:avLst>
           </a:prstGeom>
           <a:solidFill>
@@ -6981,7 +6981,7 @@
                 </a:solidFill>
                 <a:latin typeface="Poppins Medium"/>
               </a:rPr>
-              <a:t>FOTO HEADSHOT Ferry (cutout PNG)</a:t>
+              <a:t>HEADSHOT Ferry (cutout PNG)</a:t>
             </a:r>
           </a:p>
         </p:txBody>
@@ -7598,7 +7598,7 @@
         </p:nvSpPr>
         <p:spPr>
           <a:xfrm>
-            <a:off x="762000" y="2055971"/>
+            <a:off x="762000" y="2627471"/>
             <a:ext cx="8763000" cy="1000125"/>
           </a:xfrm>
           <a:prstGeom prst="rect">
@@ -7639,12 +7639,12 @@
         </p:nvSpPr>
         <p:spPr>
           <a:xfrm>
-            <a:off x="762000" y="3341846"/>
-            <a:ext cx="8763000" cy="2914650"/>
+            <a:off x="762000" y="3913346"/>
+            <a:ext cx="8763000" cy="2247900"/>
           </a:xfrm>
           <a:prstGeom prst="roundRect">
             <a:avLst>
-              <a:gd name="adj" fmla="val 13071"/>
+              <a:gd name="adj" fmla="val 16949"/>
             </a:avLst>
           </a:prstGeom>
           <a:solidFill>
@@ -7671,8 +7671,8 @@
         </p:nvSpPr>
         <p:spPr>
           <a:xfrm>
-            <a:off x="1257300" y="3799046"/>
-            <a:ext cx="7772400" cy="2000250"/>
+            <a:off x="1257300" y="4370546"/>
+            <a:ext cx="7772400" cy="1333500"/>
           </a:xfrm>
           <a:prstGeom prst="rect">
             <a:avLst/>
@@ -7697,7 +7697,7 @@
                 </a:solidFill>
                 <a:latin typeface="Poppins Medium"/>
               </a:rPr>
-              <a:t>[KUTIPAN SINGKAT NON-DATA dari Dr. Ni Gusti Made Anggraini, tema Nutrition]</a:t>
+              <a:t>[Kutipan singkat non-data dari Dr. Anggraini]</a:t>
             </a:r>
           </a:p>
         </p:txBody>
@@ -7710,7 +7710,7 @@
         </p:nvSpPr>
         <p:spPr>
           <a:xfrm>
-            <a:off x="762000" y="6542246"/>
+            <a:off x="762000" y="6446996"/>
             <a:ext cx="5583585" cy="568642"/>
           </a:xfrm>
           <a:prstGeom prst="roundRect">
@@ -7757,7 +7757,7 @@
         </p:nvSpPr>
         <p:spPr>
           <a:xfrm>
-            <a:off x="762000" y="7396639"/>
+            <a:off x="762000" y="7301389"/>
             <a:ext cx="8763000" cy="453390"/>
           </a:xfrm>
           <a:prstGeom prst="rect">
@@ -7796,12 +7796,12 @@
         </p:nvSpPr>
         <p:spPr>
           <a:xfrm>
-            <a:off x="762000" y="8135779"/>
-            <a:ext cx="8763000" cy="2286000"/>
+            <a:off x="762000" y="8040529"/>
+            <a:ext cx="8763000" cy="1809750"/>
           </a:xfrm>
           <a:prstGeom prst="roundRect">
             <a:avLst>
-              <a:gd name="adj" fmla="val 16666"/>
+              <a:gd name="adj" fmla="val 21052"/>
             </a:avLst>
           </a:prstGeom>
           <a:solidFill>
@@ -7851,7 +7851,7 @@
                 </a:solidFill>
                 <a:latin typeface="Poppins Medium"/>
               </a:rPr>
-              <a:t>FOTO HEADSHOT Dr. Anggraini (cutout PNG)</a:t>
+              <a:t>HEADSHOT Dr. Anggraini (cutout PNG)</a:t>
             </a:r>
           </a:p>
         </p:txBody>

</xml_diff>